<commit_message>
feature/step-report: paginate diameters + add --reuse fast rebuild
- Diameters slide now lists the largest diameters in up to 2 columns (max 28)
  with a "총 N개 중 상위 M개" note, so a part with hundreds of cylinders (e.g. a
  PCB assembly with 123) no longer overflows the slide. Iso render kept.
- argos_report.py --reuse: rebuild the PPTX from an existing digest.json +
  view_*.png without re-measuring or re-rendering — important for iterating on
  layout for large files (a 110 MB STEP reloads 6× otherwise).
- Planetary-gear example PPTX refreshed.
</commit_message>
<xml_diff>
--- a/examples/planetary_gear/report/HSHG17_2stage_planetary_gear_report.pptx
+++ b/examples/planetary_gear/report/HSHG17_2stage_planetary_gear_report.pptx
@@ -4683,7 +4683,7 @@
                 </a:solidFill>
                 <a:latin typeface="Malgun Gothic"/>
               </a:rPr>
-              <a:t>주요 지름 (원통면)</a:t>
+              <a:t>주요 지름 (원통면, 큰 것부터)</a:t>
             </a:r>
           </a:p>
           <a:p>
@@ -4694,7 +4694,7 @@
                 </a:solidFill>
                 <a:latin typeface="Malgun Gothic"/>
               </a:rPr>
-              <a:t>HSHG17_2stage_planetary_gear.step</a:t>
+              <a:t>HSHG17_2stage_planetary_gear.step  ·  총 16개</a:t>
             </a:r>
           </a:p>
         </p:txBody>
@@ -4708,8 +4708,8 @@
           <p:nvPr/>
         </p:nvGraphicFramePr>
         <p:xfrm>
-          <a:off x="548640" y="1280160"/>
-          <a:ext cx="5486400" cy="6217920"/>
+          <a:off x="457200" y="1280160"/>
+          <a:ext cx="2743200" cy="5486400"/>
         </p:xfrm>
         <a:graphic>
           <a:graphicData uri="http://schemas.openxmlformats.org/drawingml/2006/table">
@@ -4718,9 +4718,9 @@
                 <a:tableStyleId>{5C22544A-7EE6-4342-B048-85BDC9FD1C3A}</a:tableStyleId>
               </a:tblPr>
               <a:tblGrid>
-                <a:gridCol w="877824"/>
-                <a:gridCol w="2304288"/>
-                <a:gridCol w="2304288"/>
+                <a:gridCol w="603504"/>
+                <a:gridCol w="1152144"/>
+                <a:gridCol w="987552"/>
               </a:tblGrid>
               <a:tr h="365760">
                 <a:tc>
@@ -4729,7 +4729,7 @@
                     <a:lstStyle/>
                     <a:p>
                       <a:r>
-                        <a:rPr sz="1300" b="1">
+                        <a:rPr sz="1100" b="1">
                           <a:solidFill>
                             <a:srgbClr val="FFFFFF"/>
                           </a:solidFill>
@@ -4751,13 +4751,13 @@
                     <a:lstStyle/>
                     <a:p>
                       <a:r>
-                        <a:rPr sz="1300" b="1">
+                        <a:rPr sz="1100" b="1">
                           <a:solidFill>
                             <a:srgbClr val="FFFFFF"/>
                           </a:solidFill>
                           <a:latin typeface="Malgun Gothic"/>
                         </a:rPr>
-                        <a:t>지름 (mm)</a:t>
+                        <a:t>지름(mm)</a:t>
                       </a:r>
                     </a:p>
                   </a:txBody>
@@ -4773,13 +4773,13 @@
                     <a:lstStyle/>
                     <a:p>
                       <a:r>
-                        <a:rPr sz="1300" b="1">
+                        <a:rPr sz="1100" b="1">
                           <a:solidFill>
                             <a:srgbClr val="FFFFFF"/>
                           </a:solidFill>
                           <a:latin typeface="Malgun Gothic"/>
                         </a:rPr>
-                        <a:t>반경 (mm)</a:t>
+                        <a:t>반경(mm)</a:t>
                       </a:r>
                     </a:p>
                   </a:txBody>
@@ -4797,7 +4797,7 @@
                     <a:lstStyle/>
                     <a:p>
                       <a:r>
-                        <a:rPr sz="1300">
+                        <a:rPr sz="1100">
                           <a:solidFill>
                             <a:srgbClr val="222426"/>
                           </a:solidFill>
@@ -4819,7 +4819,7 @@
                     <a:lstStyle/>
                     <a:p>
                       <a:r>
-                        <a:rPr sz="1300">
+                        <a:rPr sz="1100">
                           <a:solidFill>
                             <a:srgbClr val="222426"/>
                           </a:solidFill>
@@ -4841,7 +4841,7 @@
                     <a:lstStyle/>
                     <a:p>
                       <a:r>
-                        <a:rPr sz="1300">
+                        <a:rPr sz="1100">
                           <a:solidFill>
                             <a:srgbClr val="222426"/>
                           </a:solidFill>
@@ -4865,7 +4865,7 @@
                     <a:lstStyle/>
                     <a:p>
                       <a:r>
-                        <a:rPr sz="1300">
+                        <a:rPr sz="1100">
                           <a:solidFill>
                             <a:srgbClr val="222426"/>
                           </a:solidFill>
@@ -4887,7 +4887,7 @@
                     <a:lstStyle/>
                     <a:p>
                       <a:r>
-                        <a:rPr sz="1300">
+                        <a:rPr sz="1100">
                           <a:solidFill>
                             <a:srgbClr val="222426"/>
                           </a:solidFill>
@@ -4909,7 +4909,7 @@
                     <a:lstStyle/>
                     <a:p>
                       <a:r>
-                        <a:rPr sz="1300">
+                        <a:rPr sz="1100">
                           <a:solidFill>
                             <a:srgbClr val="222426"/>
                           </a:solidFill>
@@ -4933,7 +4933,7 @@
                     <a:lstStyle/>
                     <a:p>
                       <a:r>
-                        <a:rPr sz="1300">
+                        <a:rPr sz="1100">
                           <a:solidFill>
                             <a:srgbClr val="222426"/>
                           </a:solidFill>
@@ -4955,7 +4955,7 @@
                     <a:lstStyle/>
                     <a:p>
                       <a:r>
-                        <a:rPr sz="1300">
+                        <a:rPr sz="1100">
                           <a:solidFill>
                             <a:srgbClr val="222426"/>
                           </a:solidFill>
@@ -4977,7 +4977,7 @@
                     <a:lstStyle/>
                     <a:p>
                       <a:r>
-                        <a:rPr sz="1300">
+                        <a:rPr sz="1100">
                           <a:solidFill>
                             <a:srgbClr val="222426"/>
                           </a:solidFill>
@@ -5001,7 +5001,7 @@
                     <a:lstStyle/>
                     <a:p>
                       <a:r>
-                        <a:rPr sz="1300">
+                        <a:rPr sz="1100">
                           <a:solidFill>
                             <a:srgbClr val="222426"/>
                           </a:solidFill>
@@ -5023,7 +5023,7 @@
                     <a:lstStyle/>
                     <a:p>
                       <a:r>
-                        <a:rPr sz="1300">
+                        <a:rPr sz="1100">
                           <a:solidFill>
                             <a:srgbClr val="222426"/>
                           </a:solidFill>
@@ -5045,7 +5045,7 @@
                     <a:lstStyle/>
                     <a:p>
                       <a:r>
-                        <a:rPr sz="1300">
+                        <a:rPr sz="1100">
                           <a:solidFill>
                             <a:srgbClr val="222426"/>
                           </a:solidFill>
@@ -5069,7 +5069,7 @@
                     <a:lstStyle/>
                     <a:p>
                       <a:r>
-                        <a:rPr sz="1300">
+                        <a:rPr sz="1100">
                           <a:solidFill>
                             <a:srgbClr val="222426"/>
                           </a:solidFill>
@@ -5091,7 +5091,7 @@
                     <a:lstStyle/>
                     <a:p>
                       <a:r>
-                        <a:rPr sz="1300">
+                        <a:rPr sz="1100">
                           <a:solidFill>
                             <a:srgbClr val="222426"/>
                           </a:solidFill>
@@ -5113,7 +5113,7 @@
                     <a:lstStyle/>
                     <a:p>
                       <a:r>
-                        <a:rPr sz="1300">
+                        <a:rPr sz="1100">
                           <a:solidFill>
                             <a:srgbClr val="222426"/>
                           </a:solidFill>
@@ -5137,7 +5137,7 @@
                     <a:lstStyle/>
                     <a:p>
                       <a:r>
-                        <a:rPr sz="1300">
+                        <a:rPr sz="1100">
                           <a:solidFill>
                             <a:srgbClr val="222426"/>
                           </a:solidFill>
@@ -5159,7 +5159,7 @@
                     <a:lstStyle/>
                     <a:p>
                       <a:r>
-                        <a:rPr sz="1300">
+                        <a:rPr sz="1100">
                           <a:solidFill>
                             <a:srgbClr val="222426"/>
                           </a:solidFill>
@@ -5181,7 +5181,7 @@
                     <a:lstStyle/>
                     <a:p>
                       <a:r>
-                        <a:rPr sz="1300">
+                        <a:rPr sz="1100">
                           <a:solidFill>
                             <a:srgbClr val="222426"/>
                           </a:solidFill>
@@ -5205,7 +5205,7 @@
                     <a:lstStyle/>
                     <a:p>
                       <a:r>
-                        <a:rPr sz="1300">
+                        <a:rPr sz="1100">
                           <a:solidFill>
                             <a:srgbClr val="222426"/>
                           </a:solidFill>
@@ -5227,7 +5227,7 @@
                     <a:lstStyle/>
                     <a:p>
                       <a:r>
-                        <a:rPr sz="1300">
+                        <a:rPr sz="1100">
                           <a:solidFill>
                             <a:srgbClr val="222426"/>
                           </a:solidFill>
@@ -5249,7 +5249,7 @@
                     <a:lstStyle/>
                     <a:p>
                       <a:r>
-                        <a:rPr sz="1300">
+                        <a:rPr sz="1100">
                           <a:solidFill>
                             <a:srgbClr val="222426"/>
                           </a:solidFill>
@@ -5273,7 +5273,7 @@
                     <a:lstStyle/>
                     <a:p>
                       <a:r>
-                        <a:rPr sz="1300">
+                        <a:rPr sz="1100">
                           <a:solidFill>
                             <a:srgbClr val="222426"/>
                           </a:solidFill>
@@ -5295,7 +5295,7 @@
                     <a:lstStyle/>
                     <a:p>
                       <a:r>
-                        <a:rPr sz="1300">
+                        <a:rPr sz="1100">
                           <a:solidFill>
                             <a:srgbClr val="222426"/>
                           </a:solidFill>
@@ -5317,7 +5317,7 @@
                     <a:lstStyle/>
                     <a:p>
                       <a:r>
-                        <a:rPr sz="1300">
+                        <a:rPr sz="1100">
                           <a:solidFill>
                             <a:srgbClr val="222426"/>
                           </a:solidFill>
@@ -5341,7 +5341,7 @@
                     <a:lstStyle/>
                     <a:p>
                       <a:r>
-                        <a:rPr sz="1300">
+                        <a:rPr sz="1100">
                           <a:solidFill>
                             <a:srgbClr val="222426"/>
                           </a:solidFill>
@@ -5363,7 +5363,7 @@
                     <a:lstStyle/>
                     <a:p>
                       <a:r>
-                        <a:rPr sz="1300">
+                        <a:rPr sz="1100">
                           <a:solidFill>
                             <a:srgbClr val="222426"/>
                           </a:solidFill>
@@ -5385,7 +5385,7 @@
                     <a:lstStyle/>
                     <a:p>
                       <a:r>
-                        <a:rPr sz="1300">
+                        <a:rPr sz="1100">
                           <a:solidFill>
                             <a:srgbClr val="222426"/>
                           </a:solidFill>
@@ -5409,7 +5409,7 @@
                     <a:lstStyle/>
                     <a:p>
                       <a:r>
-                        <a:rPr sz="1300">
+                        <a:rPr sz="1100">
                           <a:solidFill>
                             <a:srgbClr val="222426"/>
                           </a:solidFill>
@@ -5431,7 +5431,7 @@
                     <a:lstStyle/>
                     <a:p>
                       <a:r>
-                        <a:rPr sz="1300">
+                        <a:rPr sz="1100">
                           <a:solidFill>
                             <a:srgbClr val="222426"/>
                           </a:solidFill>
@@ -5453,7 +5453,7 @@
                     <a:lstStyle/>
                     <a:p>
                       <a:r>
-                        <a:rPr sz="1300">
+                        <a:rPr sz="1100">
                           <a:solidFill>
                             <a:srgbClr val="222426"/>
                           </a:solidFill>
@@ -5477,7 +5477,7 @@
                     <a:lstStyle/>
                     <a:p>
                       <a:r>
-                        <a:rPr sz="1300">
+                        <a:rPr sz="1100">
                           <a:solidFill>
                             <a:srgbClr val="222426"/>
                           </a:solidFill>
@@ -5499,7 +5499,7 @@
                     <a:lstStyle/>
                     <a:p>
                       <a:r>
-                        <a:rPr sz="1300">
+                        <a:rPr sz="1100">
                           <a:solidFill>
                             <a:srgbClr val="222426"/>
                           </a:solidFill>
@@ -5521,7 +5521,7 @@
                     <a:lstStyle/>
                     <a:p>
                       <a:r>
-                        <a:rPr sz="1300">
+                        <a:rPr sz="1100">
                           <a:solidFill>
                             <a:srgbClr val="222426"/>
                           </a:solidFill>
@@ -5545,7 +5545,7 @@
                     <a:lstStyle/>
                     <a:p>
                       <a:r>
-                        <a:rPr sz="1300">
+                        <a:rPr sz="1100">
                           <a:solidFill>
                             <a:srgbClr val="222426"/>
                           </a:solidFill>
@@ -5567,7 +5567,7 @@
                     <a:lstStyle/>
                     <a:p>
                       <a:r>
-                        <a:rPr sz="1300">
+                        <a:rPr sz="1100">
                           <a:solidFill>
                             <a:srgbClr val="222426"/>
                           </a:solidFill>
@@ -5589,7 +5589,7 @@
                     <a:lstStyle/>
                     <a:p>
                       <a:r>
-                        <a:rPr sz="1300">
+                        <a:rPr sz="1100">
                           <a:solidFill>
                             <a:srgbClr val="222426"/>
                           </a:solidFill>
@@ -5613,7 +5613,7 @@
                     <a:lstStyle/>
                     <a:p>
                       <a:r>
-                        <a:rPr sz="1300">
+                        <a:rPr sz="1100">
                           <a:solidFill>
                             <a:srgbClr val="222426"/>
                           </a:solidFill>
@@ -5635,7 +5635,7 @@
                     <a:lstStyle/>
                     <a:p>
                       <a:r>
-                        <a:rPr sz="1300">
+                        <a:rPr sz="1100">
                           <a:solidFill>
                             <a:srgbClr val="222426"/>
                           </a:solidFill>
@@ -5657,7 +5657,7 @@
                     <a:lstStyle/>
                     <a:p>
                       <a:r>
-                        <a:rPr sz="1300">
+                        <a:rPr sz="1100">
                           <a:solidFill>
                             <a:srgbClr val="222426"/>
                           </a:solidFill>
@@ -5681,7 +5681,7 @@
                     <a:lstStyle/>
                     <a:p>
                       <a:r>
-                        <a:rPr sz="1300">
+                        <a:rPr sz="1100">
                           <a:solidFill>
                             <a:srgbClr val="222426"/>
                           </a:solidFill>
@@ -5703,7 +5703,7 @@
                     <a:lstStyle/>
                     <a:p>
                       <a:r>
-                        <a:rPr sz="1300">
+                        <a:rPr sz="1100">
                           <a:solidFill>
                             <a:srgbClr val="222426"/>
                           </a:solidFill>
@@ -5725,7 +5725,7 @@
                     <a:lstStyle/>
                     <a:p>
                       <a:r>
-                        <a:rPr sz="1300">
+                        <a:rPr sz="1100">
                           <a:solidFill>
                             <a:srgbClr val="222426"/>
                           </a:solidFill>
@@ -5738,6 +5738,101 @@
                   <a:tcPr anchor="ctr" marL="73152" marT="18288" marB="18288">
                     <a:solidFill>
                       <a:srgbClr val="FFFFFF"/>
+                    </a:solidFill>
+                  </a:tcPr>
+                </a:tc>
+              </a:tr>
+            </a:tbl>
+          </a:graphicData>
+        </a:graphic>
+      </p:graphicFrame>
+      <p:graphicFrame>
+        <p:nvGraphicFramePr>
+          <p:cNvPr id="4" name="Table 3"/>
+          <p:cNvGraphicFramePr>
+            <a:graphicFrameLocks noGrp="1"/>
+          </p:cNvGraphicFramePr>
+          <p:nvPr/>
+        </p:nvGraphicFramePr>
+        <p:xfrm>
+          <a:off x="3364992" y="1280160"/>
+          <a:ext cx="2743200" cy="1097280"/>
+        </p:xfrm>
+        <a:graphic>
+          <a:graphicData uri="http://schemas.openxmlformats.org/drawingml/2006/table">
+            <a:tbl>
+              <a:tblPr firstRow="1" bandRow="1">
+                <a:tableStyleId>{5C22544A-7EE6-4342-B048-85BDC9FD1C3A}</a:tableStyleId>
+              </a:tblPr>
+              <a:tblGrid>
+                <a:gridCol w="603504"/>
+                <a:gridCol w="1152144"/>
+                <a:gridCol w="987552"/>
+              </a:tblGrid>
+              <a:tr h="365760">
+                <a:tc>
+                  <a:txBody>
+                    <a:bodyPr/>
+                    <a:lstStyle/>
+                    <a:p>
+                      <a:r>
+                        <a:rPr sz="1100" b="1">
+                          <a:solidFill>
+                            <a:srgbClr val="FFFFFF"/>
+                          </a:solidFill>
+                          <a:latin typeface="Malgun Gothic"/>
+                        </a:rPr>
+                        <a:t>#</a:t>
+                      </a:r>
+                    </a:p>
+                  </a:txBody>
+                  <a:tcPr anchor="ctr" marL="73152" marT="18288" marB="18288">
+                    <a:solidFill>
+                      <a:srgbClr val="1F6FC2"/>
+                    </a:solidFill>
+                  </a:tcPr>
+                </a:tc>
+                <a:tc>
+                  <a:txBody>
+                    <a:bodyPr/>
+                    <a:lstStyle/>
+                    <a:p>
+                      <a:r>
+                        <a:rPr sz="1100" b="1">
+                          <a:solidFill>
+                            <a:srgbClr val="FFFFFF"/>
+                          </a:solidFill>
+                          <a:latin typeface="Malgun Gothic"/>
+                        </a:rPr>
+                        <a:t>지름(mm)</a:t>
+                      </a:r>
+                    </a:p>
+                  </a:txBody>
+                  <a:tcPr anchor="ctr" marL="73152" marT="18288" marB="18288">
+                    <a:solidFill>
+                      <a:srgbClr val="1F6FC2"/>
+                    </a:solidFill>
+                  </a:tcPr>
+                </a:tc>
+                <a:tc>
+                  <a:txBody>
+                    <a:bodyPr/>
+                    <a:lstStyle/>
+                    <a:p>
+                      <a:r>
+                        <a:rPr sz="1100" b="1">
+                          <a:solidFill>
+                            <a:srgbClr val="FFFFFF"/>
+                          </a:solidFill>
+                          <a:latin typeface="Malgun Gothic"/>
+                        </a:rPr>
+                        <a:t>반경(mm)</a:t>
+                      </a:r>
+                    </a:p>
+                  </a:txBody>
+                  <a:tcPr anchor="ctr" marL="73152" marT="18288" marB="18288">
+                    <a:solidFill>
+                      <a:srgbClr val="1F6FC2"/>
                     </a:solidFill>
                   </a:tcPr>
                 </a:tc>
@@ -5749,7 +5844,7 @@
                     <a:lstStyle/>
                     <a:p>
                       <a:r>
-                        <a:rPr sz="1300">
+                        <a:rPr sz="1100">
                           <a:solidFill>
                             <a:srgbClr val="222426"/>
                           </a:solidFill>
@@ -5771,7 +5866,7 @@
                     <a:lstStyle/>
                     <a:p>
                       <a:r>
-                        <a:rPr sz="1300">
+                        <a:rPr sz="1100">
                           <a:solidFill>
                             <a:srgbClr val="222426"/>
                           </a:solidFill>
@@ -5793,7 +5888,7 @@
                     <a:lstStyle/>
                     <a:p>
                       <a:r>
-                        <a:rPr sz="1300">
+                        <a:rPr sz="1100">
                           <a:solidFill>
                             <a:srgbClr val="222426"/>
                           </a:solidFill>
@@ -5817,7 +5912,7 @@
                     <a:lstStyle/>
                     <a:p>
                       <a:r>
-                        <a:rPr sz="1300">
+                        <a:rPr sz="1100">
                           <a:solidFill>
                             <a:srgbClr val="222426"/>
                           </a:solidFill>
@@ -5839,7 +5934,7 @@
                     <a:lstStyle/>
                     <a:p>
                       <a:r>
-                        <a:rPr sz="1300">
+                        <a:rPr sz="1100">
                           <a:solidFill>
                             <a:srgbClr val="222426"/>
                           </a:solidFill>
@@ -5861,7 +5956,7 @@
                     <a:lstStyle/>
                     <a:p>
                       <a:r>
-                        <a:rPr sz="1300">
+                        <a:rPr sz="1100">
                           <a:solidFill>
                             <a:srgbClr val="222426"/>
                           </a:solidFill>
@@ -5884,7 +5979,7 @@
       </p:graphicFrame>
       <p:pic>
         <p:nvPicPr>
-          <p:cNvPr id="4" name="Picture 3" descr="view_iso.png"/>
+          <p:cNvPr id="5" name="Picture 4" descr="view_iso.png"/>
           <p:cNvPicPr>
             <a:picLocks noChangeAspect="1"/>
           </p:cNvPicPr>
@@ -5898,7 +5993,7 @@
         </p:blipFill>
         <p:spPr>
           <a:xfrm>
-            <a:off x="6400800" y="1417320"/>
+            <a:off x="6446520" y="1417320"/>
             <a:ext cx="5303520" cy="3977640"/>
           </a:xfrm>
           <a:prstGeom prst="rect">
@@ -5913,13 +6008,13 @@
       </p:pic>
       <p:sp>
         <p:nvSpPr>
-          <p:cNvPr id="5" name="TextBox 4"/>
+          <p:cNvPr id="6" name="TextBox 5"/>
           <p:cNvSpPr txBox="1"/>
           <p:nvPr/>
         </p:nvSpPr>
         <p:spPr>
           <a:xfrm>
-            <a:off x="6400800" y="5422392"/>
+            <a:off x="6446520" y="5422392"/>
             <a:ext cx="5303520" cy="320040"/>
           </a:xfrm>
           <a:prstGeom prst="rect">

</xml_diff>

<commit_message>
feature/step-report: dimension annotations on views + all-views page
Addresses feedback that you couldn't tell which direction was width vs height,
and the request for one page with front/back/side/iso together.

- annotate_image(): draws red dimension arrows + Korean labels ("가로 X = …mm",
  "세로 Z = …mm") right on each orthographic render, hugging the part silhouette
  (detected by thresholding the light background). Sizes scale with the image so
  labels stay legible when shrunk into a grid.
- New "전체 뷰 — 앞·뒤·옆·등각" slide: 2x2 grid of front/back/side(right)/iso on a
  single page, ortho views annotated with their in-plane dimensions. Replaces the
  earlier un-annotated 3-view slide. Added a back view (camera 0,1,0); dropped top.
- render_views --reuse now renders only the missing views (e.g. the new back),
  reusing the rest — so a 110 MB STEP doesn't reload 4x.

Planetary-gear example regenerated with annotated views + the new page.
</commit_message>
<xml_diff>
--- a/examples/planetary_gear/report/HSHG17_2stage_planetary_gear_report.pptx
+++ b/examples/planetary_gear/report/HSHG17_2stage_planetary_gear_report.pptx
@@ -3696,7 +3696,7 @@
                 </a:solidFill>
                 <a:latin typeface="Malgun Gothic"/>
               </a:rPr>
-              <a:t>주요 뷰 — 측정 위치</a:t>
+              <a:t>전체 뷰 — 앞 · 뒤 · 옆 · 등각</a:t>
             </a:r>
           </a:p>
           <a:p>
@@ -3707,14 +3707,14 @@
                 </a:solidFill>
                 <a:latin typeface="Malgun Gothic"/>
               </a:rPr>
-              <a:t>HSHG17_2stage_planetary_gear.step</a:t>
+              <a:t>HSHG17_2stage_planetary_gear.step  ·  치수(가로/세로)가 이미지에 표시됨</a:t>
             </a:r>
           </a:p>
         </p:txBody>
       </p:sp>
       <p:pic>
         <p:nvPicPr>
-          <p:cNvPr id="3" name="Picture 2" descr="view_front.png"/>
+          <p:cNvPr id="3" name="Picture 2" descr="view_front_dim.png"/>
           <p:cNvPicPr>
             <a:picLocks noChangeAspect="1"/>
           </p:cNvPicPr>
@@ -3728,8 +3728,8 @@
         </p:blipFill>
         <p:spPr>
           <a:xfrm>
-            <a:off x="320040" y="1325880"/>
-            <a:ext cx="3886200" cy="2914650"/>
+            <a:off x="1583420" y="1188720"/>
+            <a:ext cx="3051080" cy="2331720"/>
           </a:xfrm>
           <a:prstGeom prst="rect">
             <a:avLst/>
@@ -3749,8 +3749,8 @@
         </p:nvSpPr>
         <p:spPr>
           <a:xfrm>
-            <a:off x="320040" y="4267962"/>
-            <a:ext cx="3886200" cy="320040"/>
+            <a:off x="411480" y="3547872"/>
+            <a:ext cx="5394960" cy="320040"/>
           </a:xfrm>
           <a:prstGeom prst="rect">
             <a:avLst/>
@@ -3771,14 +3771,14 @@
                 </a:solidFill>
                 <a:latin typeface="Malgun Gothic"/>
               </a:rPr>
-              <a:t>정면도 — 폭(X) × 높이(Z)</a:t>
+              <a:t>앞면 (Front)</a:t>
             </a:r>
           </a:p>
         </p:txBody>
       </p:sp>
       <p:pic>
         <p:nvPicPr>
-          <p:cNvPr id="5" name="Picture 4" descr="view_top.png"/>
+          <p:cNvPr id="5" name="Picture 4" descr="view_back_dim.png"/>
           <p:cNvPicPr>
             <a:picLocks noChangeAspect="1"/>
           </p:cNvPicPr>
@@ -3792,8 +3792,8 @@
         </p:blipFill>
         <p:spPr>
           <a:xfrm>
-            <a:off x="4160520" y="1325880"/>
-            <a:ext cx="3886200" cy="2914650"/>
+            <a:off x="7527020" y="1188720"/>
+            <a:ext cx="3051080" cy="2331720"/>
           </a:xfrm>
           <a:prstGeom prst="rect">
             <a:avLst/>
@@ -3813,8 +3813,8 @@
         </p:nvSpPr>
         <p:spPr>
           <a:xfrm>
-            <a:off x="4160520" y="4267962"/>
-            <a:ext cx="3886200" cy="320040"/>
+            <a:off x="6355080" y="3547872"/>
+            <a:ext cx="5394960" cy="320040"/>
           </a:xfrm>
           <a:prstGeom prst="rect">
             <a:avLst/>
@@ -3835,14 +3835,14 @@
                 </a:solidFill>
                 <a:latin typeface="Malgun Gothic"/>
               </a:rPr>
-              <a:t>윗면도 — 길이(X) × 폭(Y)</a:t>
+              <a:t>뒷면 (Back)</a:t>
             </a:r>
           </a:p>
         </p:txBody>
       </p:sp>
       <p:pic>
         <p:nvPicPr>
-          <p:cNvPr id="7" name="Picture 6" descr="view_right.png"/>
+          <p:cNvPr id="7" name="Picture 6" descr="view_right_dim.png"/>
           <p:cNvPicPr>
             <a:picLocks noChangeAspect="1"/>
           </p:cNvPicPr>
@@ -3856,8 +3856,8 @@
         </p:blipFill>
         <p:spPr>
           <a:xfrm>
-            <a:off x="8001000" y="1325880"/>
-            <a:ext cx="3886200" cy="2914650"/>
+            <a:off x="1583420" y="4069080"/>
+            <a:ext cx="3051080" cy="2331720"/>
           </a:xfrm>
           <a:prstGeom prst="rect">
             <a:avLst/>
@@ -3877,8 +3877,8 @@
         </p:nvSpPr>
         <p:spPr>
           <a:xfrm>
-            <a:off x="8001000" y="4267962"/>
-            <a:ext cx="3886200" cy="320040"/>
+            <a:off x="411480" y="6428232"/>
+            <a:ext cx="5394960" cy="320040"/>
           </a:xfrm>
           <a:prstGeom prst="rect">
             <a:avLst/>
@@ -3899,7 +3899,71 @@
                 </a:solidFill>
                 <a:latin typeface="Malgun Gothic"/>
               </a:rPr>
-              <a:t>측면도 — 폭(Y) × 높이(Z)</a:t>
+              <a:t>옆면 (Side)</a:t>
+            </a:r>
+          </a:p>
+        </p:txBody>
+      </p:sp>
+      <p:pic>
+        <p:nvPicPr>
+          <p:cNvPr id="9" name="Picture 8" descr="view_iso.png"/>
+          <p:cNvPicPr>
+            <a:picLocks noChangeAspect="1"/>
+          </p:cNvPicPr>
+          <p:nvPr/>
+        </p:nvPicPr>
+        <p:blipFill>
+          <a:blip r:embed="rId5"/>
+          <a:stretch>
+            <a:fillRect/>
+          </a:stretch>
+        </p:blipFill>
+        <p:spPr>
+          <a:xfrm>
+            <a:off x="7498080" y="4069080"/>
+            <a:ext cx="3108960" cy="2331720"/>
+          </a:xfrm>
+          <a:prstGeom prst="rect">
+            <a:avLst/>
+          </a:prstGeom>
+          <a:ln w="9525">
+            <a:solidFill>
+              <a:srgbClr val="CFD6DE"/>
+            </a:solidFill>
+          </a:ln>
+        </p:spPr>
+      </p:pic>
+      <p:sp>
+        <p:nvSpPr>
+          <p:cNvPr id="10" name="TextBox 9"/>
+          <p:cNvSpPr txBox="1"/>
+          <p:nvPr/>
+        </p:nvSpPr>
+        <p:spPr>
+          <a:xfrm>
+            <a:off x="6355080" y="6428232"/>
+            <a:ext cx="5394960" cy="320040"/>
+          </a:xfrm>
+          <a:prstGeom prst="rect">
+            <a:avLst/>
+          </a:prstGeom>
+          <a:noFill/>
+        </p:spPr>
+        <p:txBody>
+          <a:bodyPr wrap="square">
+            <a:spAutoFit/>
+          </a:bodyPr>
+          <a:lstStyle/>
+          <a:p>
+            <a:pPr algn="ctr"/>
+            <a:r>
+              <a:rPr sz="1100" b="0">
+                <a:solidFill>
+                  <a:srgbClr val="6A6E73"/>
+                </a:solidFill>
+                <a:latin typeface="Malgun Gothic"/>
+              </a:rPr>
+              <a:t>등각투영 (ISO)</a:t>
             </a:r>
           </a:p>
         </p:txBody>

</xml_diff>

<commit_message>
feature/step-report: refocus report on size + multi-angle photos
Per request, the default report is now visual/dimensional rather than
robot-dynamics oriented:
- Mass / inertia / URDF slides are OFF by default (add back with --with-mass).
  URDF is only computed/written when --with-mass is given.
- Dimensions stated as 가로(X) · 세로(Y) · 높이(Z); each orthographic view is
  annotated with its in-plane dims using these names (consistent everywhere).
- Standard 삼면도: front / TOP / side + iso. Top replaces the redundant back
  view and shows the footprint — fixes flat parts (a PCB only reads from above).
- New "여러 각도" gallery: 4 isometric corners (turntable). Title slide shows
  the part + size.

Slides: title / dimensions / dimensioned-drawing / multi-angle / diameters.
Planetary-gear example regenerated (7 renders); URDF file dropped from it.
</commit_message>
<xml_diff>
--- a/examples/planetary_gear/report/HSHG17_2stage_planetary_gear_report.pptx
+++ b/examples/planetary_gear/report/HSHG17_2stage_planetary_gear_report.pptx
@@ -10,7 +10,6 @@
     <p:sldId id="258" r:id="rId9"/>
     <p:sldId id="259" r:id="rId10"/>
     <p:sldId id="260" r:id="rId11"/>
-    <p:sldId id="261" r:id="rId12"/>
   </p:sldIdLst>
   <p:sldSz cx="12191695" cy="6858000" type="screen4x3"/>
   <p:notesSz cx="6858000" cy="9144000"/>
@@ -3144,7 +3143,7 @@
         </p:nvSpPr>
         <p:spPr>
           <a:xfrm>
-            <a:off x="731520" y="2194560"/>
+            <a:off x="731520" y="868680"/>
             <a:ext cx="10698480" cy="1097280"/>
           </a:xfrm>
           <a:prstGeom prst="rect">
@@ -3179,8 +3178,8 @@
         </p:nvSpPr>
         <p:spPr>
           <a:xfrm>
-            <a:off x="777240" y="3383280"/>
-            <a:ext cx="10698480" cy="1828800"/>
+            <a:off x="777240" y="1965960"/>
+            <a:ext cx="10698480" cy="1097280"/>
           </a:xfrm>
           <a:prstGeom prst="rect">
             <a:avLst/>
@@ -3213,23 +3212,40 @@
                 </a:solidFill>
                 <a:latin typeface="Malgun Gothic"/>
               </a:rPr>
-              <a:t>재료/밀도: 강철(steel)</a:t>
-            </a:r>
-          </a:p>
-          <a:p>
-            <a:pPr algn="l"/>
-            <a:r>
-              <a:rPr sz="1600" b="0">
-                <a:solidFill>
-                  <a:srgbClr val="CFDDEE"/>
-                </a:solidFill>
-                <a:latin typeface="Malgun Gothic"/>
-              </a:rPr>
-              <a:t>생성: Argos (argos-cli digest/props)</a:t>
-            </a:r>
-          </a:p>
-        </p:txBody>
-      </p:sp>
+              <a:t>크기: 가로 49.2 × 세로 49.2 × 높이 93.0 mm</a:t>
+            </a:r>
+          </a:p>
+        </p:txBody>
+      </p:sp>
+      <p:pic>
+        <p:nvPicPr>
+          <p:cNvPr id="5" name="Picture 4" descr="view_iso.png"/>
+          <p:cNvPicPr>
+            <a:picLocks noChangeAspect="1"/>
+          </p:cNvPicPr>
+          <p:nvPr/>
+        </p:nvPicPr>
+        <p:blipFill>
+          <a:blip r:embed="rId2"/>
+          <a:stretch>
+            <a:fillRect/>
+          </a:stretch>
+        </p:blipFill>
+        <p:spPr>
+          <a:xfrm>
+            <a:off x="3825240" y="3154680"/>
+            <a:ext cx="4511040" cy="3383280"/>
+          </a:xfrm>
+          <a:prstGeom prst="rect">
+            <a:avLst/>
+          </a:prstGeom>
+          <a:ln w="9525">
+            <a:solidFill>
+              <a:srgbClr val="CFD6DE"/>
+            </a:solidFill>
+          </a:ln>
+        </p:spPr>
+      </p:pic>
     </p:spTree>
   </p:cSld>
   <p:clrMapOvr>
@@ -3295,7 +3311,7 @@
                 </a:solidFill>
                 <a:latin typeface="Malgun Gothic"/>
               </a:rPr>
-              <a:t>개요 · 주요 치수</a:t>
+              <a:t>주요 치수 — 가로 · 세로 · 높이</a:t>
             </a:r>
           </a:p>
           <a:p>
@@ -3320,8 +3336,8 @@
           <p:nvPr/>
         </p:nvGraphicFramePr>
         <p:xfrm>
-          <a:off x="502920" y="1325880"/>
-          <a:ext cx="6126479" cy="1828800"/>
+          <a:off x="502920" y="1371600"/>
+          <a:ext cx="5852160" cy="2560320"/>
         </p:xfrm>
         <a:graphic>
           <a:graphicData uri="http://schemas.openxmlformats.org/drawingml/2006/table">
@@ -3330,8 +3346,8 @@
                 <a:tableStyleId>{5C22544A-7EE6-4342-B048-85BDC9FD1C3A}</a:tableStyleId>
               </a:tblPr>
               <a:tblGrid>
-                <a:gridCol w="2818180"/>
-                <a:gridCol w="3308299"/>
+                <a:gridCol w="2926080"/>
+                <a:gridCol w="2926080"/>
               </a:tblGrid>
               <a:tr h="365760">
                 <a:tc>
@@ -3340,7 +3356,7 @@
                     <a:lstStyle/>
                     <a:p>
                       <a:r>
-                        <a:rPr sz="1300" b="1">
+                        <a:rPr sz="1500" b="1">
                           <a:solidFill>
                             <a:srgbClr val="FFFFFF"/>
                           </a:solidFill>
@@ -3362,7 +3378,7 @@
                     <a:lstStyle/>
                     <a:p>
                       <a:r>
-                        <a:rPr sz="1300" b="1">
+                        <a:rPr sz="1500" b="1">
                           <a:solidFill>
                             <a:srgbClr val="FFFFFF"/>
                           </a:solidFill>
@@ -3386,13 +3402,13 @@
                     <a:lstStyle/>
                     <a:p>
                       <a:r>
-                        <a:rPr sz="1300">
+                        <a:rPr sz="1500">
                           <a:solidFill>
                             <a:srgbClr val="222426"/>
                           </a:solidFill>
                           <a:latin typeface="Malgun Gothic"/>
                         </a:rPr>
-                        <a:t>전체 치수 (L×W×H)</a:t>
+                        <a:t>가로 (X)</a:t>
                       </a:r>
                     </a:p>
                   </a:txBody>
@@ -3408,13 +3424,13 @@
                     <a:lstStyle/>
                     <a:p>
                       <a:r>
-                        <a:rPr sz="1300">
+                        <a:rPr sz="1500">
                           <a:solidFill>
                             <a:srgbClr val="222426"/>
                           </a:solidFill>
                           <a:latin typeface="Malgun Gothic"/>
                         </a:rPr>
-                        <a:t>49.17 × 49.17 × 93.00 mm</a:t>
+                        <a:t>49.17 mm</a:t>
                       </a:r>
                     </a:p>
                   </a:txBody>
@@ -3432,13 +3448,13 @@
                     <a:lstStyle/>
                     <a:p>
                       <a:r>
-                        <a:rPr sz="1300">
+                        <a:rPr sz="1500">
                           <a:solidFill>
                             <a:srgbClr val="222426"/>
                           </a:solidFill>
                           <a:latin typeface="Malgun Gothic"/>
                         </a:rPr>
-                        <a:t>부피</a:t>
+                        <a:t>세로 (Y)</a:t>
                       </a:r>
                     </a:p>
                   </a:txBody>
@@ -3454,13 +3470,13 @@
                     <a:lstStyle/>
                     <a:p>
                       <a:r>
-                        <a:rPr sz="1300">
+                        <a:rPr sz="1500">
                           <a:solidFill>
                             <a:srgbClr val="222426"/>
                           </a:solidFill>
                           <a:latin typeface="Malgun Gothic"/>
                         </a:rPr>
-                        <a:t>103,467.00 mm³  (103.47 cm³)</a:t>
+                        <a:t>49.17 mm</a:t>
                       </a:r>
                     </a:p>
                   </a:txBody>
@@ -3478,13 +3494,13 @@
                     <a:lstStyle/>
                     <a:p>
                       <a:r>
-                        <a:rPr sz="1300">
+                        <a:rPr sz="1500">
                           <a:solidFill>
                             <a:srgbClr val="222426"/>
                           </a:solidFill>
                           <a:latin typeface="Malgun Gothic"/>
                         </a:rPr>
-                        <a:t>표면적</a:t>
+                        <a:t>높이 (Z)</a:t>
                       </a:r>
                     </a:p>
                   </a:txBody>
@@ -3500,13 +3516,13 @@
                     <a:lstStyle/>
                     <a:p>
                       <a:r>
-                        <a:rPr sz="1300">
+                        <a:rPr sz="1500">
                           <a:solidFill>
                             <a:srgbClr val="222426"/>
                           </a:solidFill>
                           <a:latin typeface="Malgun Gothic"/>
                         </a:rPr>
-                        <a:t>20,554.35 mm²</a:t>
+                        <a:t>93.00 mm</a:t>
                       </a:r>
                     </a:p>
                   </a:txBody>
@@ -3524,12 +3540,104 @@
                     <a:lstStyle/>
                     <a:p>
                       <a:r>
-                        <a:rPr sz="1300">
+                        <a:rPr sz="1500">
                           <a:solidFill>
                             <a:srgbClr val="222426"/>
                           </a:solidFill>
                           <a:latin typeface="Malgun Gothic"/>
                         </a:rPr>
+                        <a:t>부피</a:t>
+                      </a:r>
+                    </a:p>
+                  </a:txBody>
+                  <a:tcPr anchor="ctr" marL="73152" marT="18288" marB="18288">
+                    <a:solidFill>
+                      <a:srgbClr val="FFFFFF"/>
+                    </a:solidFill>
+                  </a:tcPr>
+                </a:tc>
+                <a:tc>
+                  <a:txBody>
+                    <a:bodyPr/>
+                    <a:lstStyle/>
+                    <a:p>
+                      <a:r>
+                        <a:rPr sz="1500">
+                          <a:solidFill>
+                            <a:srgbClr val="222426"/>
+                          </a:solidFill>
+                          <a:latin typeface="Malgun Gothic"/>
+                        </a:rPr>
+                        <a:t>103.47 cm³</a:t>
+                      </a:r>
+                    </a:p>
+                  </a:txBody>
+                  <a:tcPr anchor="ctr" marL="73152" marT="18288" marB="18288">
+                    <a:solidFill>
+                      <a:srgbClr val="FFFFFF"/>
+                    </a:solidFill>
+                  </a:tcPr>
+                </a:tc>
+              </a:tr>
+              <a:tr h="365760">
+                <a:tc>
+                  <a:txBody>
+                    <a:bodyPr/>
+                    <a:lstStyle/>
+                    <a:p>
+                      <a:r>
+                        <a:rPr sz="1500">
+                          <a:solidFill>
+                            <a:srgbClr val="222426"/>
+                          </a:solidFill>
+                          <a:latin typeface="Malgun Gothic"/>
+                        </a:rPr>
+                        <a:t>표면적</a:t>
+                      </a:r>
+                    </a:p>
+                  </a:txBody>
+                  <a:tcPr anchor="ctr" marL="73152" marT="18288" marB="18288">
+                    <a:solidFill>
+                      <a:srgbClr val="F4F6F8"/>
+                    </a:solidFill>
+                  </a:tcPr>
+                </a:tc>
+                <a:tc>
+                  <a:txBody>
+                    <a:bodyPr/>
+                    <a:lstStyle/>
+                    <a:p>
+                      <a:r>
+                        <a:rPr sz="1500">
+                          <a:solidFill>
+                            <a:srgbClr val="222426"/>
+                          </a:solidFill>
+                          <a:latin typeface="Malgun Gothic"/>
+                        </a:rPr>
+                        <a:t>20,554.35 mm²</a:t>
+                      </a:r>
+                    </a:p>
+                  </a:txBody>
+                  <a:tcPr anchor="ctr" marL="73152" marT="18288" marB="18288">
+                    <a:solidFill>
+                      <a:srgbClr val="F4F6F8"/>
+                    </a:solidFill>
+                  </a:tcPr>
+                </a:tc>
+              </a:tr>
+              <a:tr h="365760">
+                <a:tc>
+                  <a:txBody>
+                    <a:bodyPr/>
+                    <a:lstStyle/>
+                    <a:p>
+                      <a:r>
+                        <a:rPr sz="1500">
+                          <a:solidFill>
+                            <a:srgbClr val="222426"/>
+                          </a:solidFill>
+                          <a:latin typeface="Malgun Gothic"/>
+                        </a:rPr>
                         <a:t>솔리드 / 면 / 모서리</a:t>
                       </a:r>
                     </a:p>
@@ -3546,7 +3654,7 @@
                     <a:lstStyle/>
                     <a:p>
                       <a:r>
-                        <a:rPr sz="1300">
+                        <a:rPr sz="1500">
                           <a:solidFill>
                             <a:srgbClr val="222426"/>
                           </a:solidFill>
@@ -3583,8 +3691,8 @@
         </p:blipFill>
         <p:spPr>
           <a:xfrm>
-            <a:off x="6812280" y="1417320"/>
-            <a:ext cx="4937760" cy="3703320"/>
+            <a:off x="6720840" y="1417320"/>
+            <a:ext cx="5029200" cy="3771900"/>
           </a:xfrm>
           <a:prstGeom prst="rect">
             <a:avLst/>
@@ -3604,8 +3712,8 @@
         </p:nvSpPr>
         <p:spPr>
           <a:xfrm>
-            <a:off x="6812280" y="5148072"/>
-            <a:ext cx="4937760" cy="320040"/>
+            <a:off x="6720840" y="5216652"/>
+            <a:ext cx="5029200" cy="320040"/>
           </a:xfrm>
           <a:prstGeom prst="rect">
             <a:avLst/>
@@ -3696,7 +3804,7 @@
                 </a:solidFill>
                 <a:latin typeface="Malgun Gothic"/>
               </a:rPr>
-              <a:t>전체 뷰 — 앞 · 뒤 · 옆 · 등각</a:t>
+              <a:t>치수 도면 — 정면 · 평면 · 측면 · 등각</a:t>
             </a:r>
           </a:p>
           <a:p>
@@ -3707,7 +3815,7 @@
                 </a:solidFill>
                 <a:latin typeface="Malgun Gothic"/>
               </a:rPr>
-              <a:t>HSHG17_2stage_planetary_gear.step  ·  치수(가로/세로)가 이미지에 표시됨</a:t>
+              <a:t>HSHG17_2stage_planetary_gear.step  ·  가로/세로/높이가 이미지에 표시됨</a:t>
             </a:r>
           </a:p>
         </p:txBody>
@@ -3771,14 +3879,14 @@
                 </a:solidFill>
                 <a:latin typeface="Malgun Gothic"/>
               </a:rPr>
-              <a:t>앞면 (Front)</a:t>
+              <a:t>정면도 (앞)</a:t>
             </a:r>
           </a:p>
         </p:txBody>
       </p:sp>
       <p:pic>
         <p:nvPicPr>
-          <p:cNvPr id="5" name="Picture 4" descr="view_back_dim.png"/>
+          <p:cNvPr id="5" name="Picture 4" descr="view_top_dim.png"/>
           <p:cNvPicPr>
             <a:picLocks noChangeAspect="1"/>
           </p:cNvPicPr>
@@ -3835,7 +3943,7 @@
                 </a:solidFill>
                 <a:latin typeface="Malgun Gothic"/>
               </a:rPr>
-              <a:t>뒷면 (Back)</a:t>
+              <a:t>평면도 (위)</a:t>
             </a:r>
           </a:p>
         </p:txBody>
@@ -3899,7 +4007,7 @@
                 </a:solidFill>
                 <a:latin typeface="Malgun Gothic"/>
               </a:rPr>
-              <a:t>옆면 (Side)</a:t>
+              <a:t>측면도 (옆)</a:t>
             </a:r>
           </a:p>
         </p:txBody>
@@ -3963,7 +4071,7 @@
                 </a:solidFill>
                 <a:latin typeface="Malgun Gothic"/>
               </a:rPr>
-              <a:t>등각투영 (ISO)</a:t>
+              <a:t>등각 (앞·우·위)</a:t>
             </a:r>
           </a:p>
         </p:txBody>
@@ -4033,7 +4141,7 @@
                 </a:solidFill>
                 <a:latin typeface="Malgun Gothic"/>
               </a:rPr>
-              <a:t>질량 특성 (휴머노이드 링크 동역학)</a:t>
+              <a:t>여러 각도 — 등각 뷰</a:t>
             </a:r>
           </a:p>
           <a:p>
@@ -4044,221 +4152,40 @@
                 </a:solidFill>
                 <a:latin typeface="Malgun Gothic"/>
               </a:rPr>
-              <a:t>HSHG17_2stage_planetary_gear.step  ·  강철(steel)</a:t>
-            </a:r>
-          </a:p>
-        </p:txBody>
-      </p:sp>
-      <p:graphicFrame>
-        <p:nvGraphicFramePr>
-          <p:cNvPr id="3" name="Table 2"/>
-          <p:cNvGraphicFramePr>
-            <a:graphicFrameLocks noGrp="1"/>
-          </p:cNvGraphicFramePr>
+              <a:t>HSHG17_2stage_planetary_gear.step</a:t>
+            </a:r>
+          </a:p>
+        </p:txBody>
+      </p:sp>
+      <p:pic>
+        <p:nvPicPr>
+          <p:cNvPr id="3" name="Picture 2" descr="view_iso.png"/>
+          <p:cNvPicPr>
+            <a:picLocks noChangeAspect="1"/>
+          </p:cNvPicPr>
           <p:nvPr/>
-        </p:nvGraphicFramePr>
-        <p:xfrm>
-          <a:off x="640080" y="1234440"/>
-          <a:ext cx="10881359" cy="1463040"/>
-        </p:xfrm>
-        <a:graphic>
-          <a:graphicData uri="http://schemas.openxmlformats.org/drawingml/2006/table">
-            <a:tbl>
-              <a:tblPr firstRow="1" bandRow="1">
-                <a:tableStyleId>{5C22544A-7EE6-4342-B048-85BDC9FD1C3A}</a:tableStyleId>
-              </a:tblPr>
-              <a:tblGrid>
-                <a:gridCol w="3699662"/>
-                <a:gridCol w="7181697"/>
-              </a:tblGrid>
-              <a:tr h="365760">
-                <a:tc>
-                  <a:txBody>
-                    <a:bodyPr/>
-                    <a:lstStyle/>
-                    <a:p>
-                      <a:r>
-                        <a:rPr sz="1300" b="1">
-                          <a:solidFill>
-                            <a:srgbClr val="FFFFFF"/>
-                          </a:solidFill>
-                          <a:latin typeface="Malgun Gothic"/>
-                        </a:rPr>
-                        <a:t>항목</a:t>
-                      </a:r>
-                    </a:p>
-                  </a:txBody>
-                  <a:tcPr anchor="ctr" marL="73152" marT="18288" marB="18288">
-                    <a:solidFill>
-                      <a:srgbClr val="1F6FC2"/>
-                    </a:solidFill>
-                  </a:tcPr>
-                </a:tc>
-                <a:tc>
-                  <a:txBody>
-                    <a:bodyPr/>
-                    <a:lstStyle/>
-                    <a:p>
-                      <a:r>
-                        <a:rPr sz="1300" b="1">
-                          <a:solidFill>
-                            <a:srgbClr val="FFFFFF"/>
-                          </a:solidFill>
-                          <a:latin typeface="Malgun Gothic"/>
-                        </a:rPr>
-                        <a:t>값</a:t>
-                      </a:r>
-                    </a:p>
-                  </a:txBody>
-                  <a:tcPr anchor="ctr" marL="73152" marT="18288" marB="18288">
-                    <a:solidFill>
-                      <a:srgbClr val="1F6FC2"/>
-                    </a:solidFill>
-                  </a:tcPr>
-                </a:tc>
-              </a:tr>
-              <a:tr h="365760">
-                <a:tc>
-                  <a:txBody>
-                    <a:bodyPr/>
-                    <a:lstStyle/>
-                    <a:p>
-                      <a:r>
-                        <a:rPr sz="1300">
-                          <a:solidFill>
-                            <a:srgbClr val="222426"/>
-                          </a:solidFill>
-                          <a:latin typeface="Malgun Gothic"/>
-                        </a:rPr>
-                        <a:t>질량</a:t>
-                      </a:r>
-                    </a:p>
-                  </a:txBody>
-                  <a:tcPr anchor="ctr" marL="73152" marT="18288" marB="18288">
-                    <a:solidFill>
-                      <a:srgbClr val="F4F6F8"/>
-                    </a:solidFill>
-                  </a:tcPr>
-                </a:tc>
-                <a:tc>
-                  <a:txBody>
-                    <a:bodyPr/>
-                    <a:lstStyle/>
-                    <a:p>
-                      <a:r>
-                        <a:rPr sz="1300">
-                          <a:solidFill>
-                            <a:srgbClr val="222426"/>
-                          </a:solidFill>
-                          <a:latin typeface="Malgun Gothic"/>
-                        </a:rPr>
-                        <a:t>0.8122 kg  (812.22 g)</a:t>
-                      </a:r>
-                    </a:p>
-                  </a:txBody>
-                  <a:tcPr anchor="ctr" marL="73152" marT="18288" marB="18288">
-                    <a:solidFill>
-                      <a:srgbClr val="F4F6F8"/>
-                    </a:solidFill>
-                  </a:tcPr>
-                </a:tc>
-              </a:tr>
-              <a:tr h="365760">
-                <a:tc>
-                  <a:txBody>
-                    <a:bodyPr/>
-                    <a:lstStyle/>
-                    <a:p>
-                      <a:r>
-                        <a:rPr sz="1300">
-                          <a:solidFill>
-                            <a:srgbClr val="222426"/>
-                          </a:solidFill>
-                          <a:latin typeface="Malgun Gothic"/>
-                        </a:rPr>
-                        <a:t>무게중심 COM (mm)</a:t>
-                      </a:r>
-                    </a:p>
-                  </a:txBody>
-                  <a:tcPr anchor="ctr" marL="73152" marT="18288" marB="18288">
-                    <a:solidFill>
-                      <a:srgbClr val="FFFFFF"/>
-                    </a:solidFill>
-                  </a:tcPr>
-                </a:tc>
-                <a:tc>
-                  <a:txBody>
-                    <a:bodyPr/>
-                    <a:lstStyle/>
-                    <a:p>
-                      <a:r>
-                        <a:rPr sz="1300">
-                          <a:solidFill>
-                            <a:srgbClr val="222426"/>
-                          </a:solidFill>
-                          <a:latin typeface="Malgun Gothic"/>
-                        </a:rPr>
-                        <a:t>(-0.000, 0.002, 39.087)</a:t>
-                      </a:r>
-                    </a:p>
-                  </a:txBody>
-                  <a:tcPr anchor="ctr" marL="73152" marT="18288" marB="18288">
-                    <a:solidFill>
-                      <a:srgbClr val="FFFFFF"/>
-                    </a:solidFill>
-                  </a:tcPr>
-                </a:tc>
-              </a:tr>
-              <a:tr h="365760">
-                <a:tc>
-                  <a:txBody>
-                    <a:bodyPr/>
-                    <a:lstStyle/>
-                    <a:p>
-                      <a:r>
-                        <a:rPr sz="1300">
-                          <a:solidFill>
-                            <a:srgbClr val="222426"/>
-                          </a:solidFill>
-                          <a:latin typeface="Malgun Gothic"/>
-                        </a:rPr>
-                        <a:t>주관성모멘트 (kg·m²)</a:t>
-                      </a:r>
-                    </a:p>
-                  </a:txBody>
-                  <a:tcPr anchor="ctr" marL="73152" marT="18288" marB="18288">
-                    <a:solidFill>
-                      <a:srgbClr val="F4F6F8"/>
-                    </a:solidFill>
-                  </a:tcPr>
-                </a:tc>
-                <a:tc>
-                  <a:txBody>
-                    <a:bodyPr/>
-                    <a:lstStyle/>
-                    <a:p>
-                      <a:r>
-                        <a:rPr sz="1300">
-                          <a:solidFill>
-                            <a:srgbClr val="222426"/>
-                          </a:solidFill>
-                          <a:latin typeface="Malgun Gothic"/>
-                        </a:rPr>
-                        <a:t>4.8533e-04,  4.8446e-04,  2.0359e-04</a:t>
-                      </a:r>
-                    </a:p>
-                  </a:txBody>
-                  <a:tcPr anchor="ctr" marL="73152" marT="18288" marB="18288">
-                    <a:solidFill>
-                      <a:srgbClr val="F4F6F8"/>
-                    </a:solidFill>
-                  </a:tcPr>
-                </a:tc>
-              </a:tr>
-            </a:tbl>
-          </a:graphicData>
-        </a:graphic>
-      </p:graphicFrame>
+        </p:nvPicPr>
+        <p:blipFill>
+          <a:blip r:embed="rId2"/>
+          <a:stretch>
+            <a:fillRect/>
+          </a:stretch>
+        </p:blipFill>
+        <p:spPr>
+          <a:xfrm>
+            <a:off x="1554480" y="1188720"/>
+            <a:ext cx="3108960" cy="2331720"/>
+          </a:xfrm>
+          <a:prstGeom prst="rect">
+            <a:avLst/>
+          </a:prstGeom>
+          <a:ln w="9525">
+            <a:solidFill>
+              <a:srgbClr val="CFD6DE"/>
+            </a:solidFill>
+          </a:ln>
+        </p:spPr>
+      </p:pic>
       <p:sp>
         <p:nvSpPr>
           <p:cNvPr id="4" name="TextBox 3"/>
@@ -4267,8 +4194,8 @@
         </p:nvSpPr>
         <p:spPr>
           <a:xfrm>
-            <a:off x="640080" y="3246120"/>
-            <a:ext cx="5486400" cy="365760"/>
+            <a:off x="411480" y="3547872"/>
+            <a:ext cx="5394960" cy="320040"/>
           </a:xfrm>
           <a:prstGeom prst="rect">
             <a:avLst/>
@@ -4281,407 +4208,211 @@
           </a:bodyPr>
           <a:lstStyle/>
           <a:p>
-            <a:pPr algn="l"/>
-            <a:r>
-              <a:rPr sz="1400" b="1">
+            <a:pPr algn="ctr"/>
+            <a:r>
+              <a:rPr sz="1100" b="0">
                 <a:solidFill>
-                  <a:srgbClr val="1F6FC2"/>
+                  <a:srgbClr val="6A6E73"/>
                 </a:solidFill>
                 <a:latin typeface="Malgun Gothic"/>
               </a:rPr>
-              <a:t>관성텐서 (COM 기준, kg·m²)</a:t>
-            </a:r>
-          </a:p>
-        </p:txBody>
-      </p:sp>
-      <p:graphicFrame>
-        <p:nvGraphicFramePr>
-          <p:cNvPr id="5" name="Table 4"/>
-          <p:cNvGraphicFramePr>
-            <a:graphicFrameLocks noGrp="1"/>
-          </p:cNvGraphicFramePr>
+              <a:t>등각 (앞·우·위)</a:t>
+            </a:r>
+          </a:p>
+        </p:txBody>
+      </p:sp>
+      <p:pic>
+        <p:nvPicPr>
+          <p:cNvPr id="5" name="Picture 4" descr="view_iso2.png"/>
+          <p:cNvPicPr>
+            <a:picLocks noChangeAspect="1"/>
+          </p:cNvPicPr>
           <p:nvPr/>
-        </p:nvGraphicFramePr>
-        <p:xfrm>
-          <a:off x="640080" y="3657600"/>
-          <a:ext cx="7498078" cy="1463040"/>
-        </p:xfrm>
-        <a:graphic>
-          <a:graphicData uri="http://schemas.openxmlformats.org/drawingml/2006/table">
-            <a:tbl>
-              <a:tblPr firstRow="1" bandRow="1">
-                <a:tableStyleId>{5C22544A-7EE6-4342-B048-85BDC9FD1C3A}</a:tableStyleId>
-              </a:tblPr>
-              <a:tblGrid>
-                <a:gridCol w="1199692"/>
-                <a:gridCol w="2099462"/>
-                <a:gridCol w="2099462"/>
-                <a:gridCol w="2099462"/>
-              </a:tblGrid>
-              <a:tr h="365760">
-                <a:tc>
-                  <a:txBody>
-                    <a:bodyPr/>
-                    <a:lstStyle/>
-                    <a:p>
-                      <a:r>
-                        <a:rPr sz="1200" b="1">
-                          <a:solidFill>
-                            <a:srgbClr val="FFFFFF"/>
-                          </a:solidFill>
-                          <a:latin typeface="Malgun Gothic"/>
-                        </a:rPr>
-                        <a:t/>
-                      </a:r>
-                    </a:p>
-                  </a:txBody>
-                  <a:tcPr anchor="ctr" marL="73152" marT="18288" marB="18288">
-                    <a:solidFill>
-                      <a:srgbClr val="1F6FC2"/>
-                    </a:solidFill>
-                  </a:tcPr>
-                </a:tc>
-                <a:tc>
-                  <a:txBody>
-                    <a:bodyPr/>
-                    <a:lstStyle/>
-                    <a:p>
-                      <a:r>
-                        <a:rPr sz="1200" b="1">
-                          <a:solidFill>
-                            <a:srgbClr val="FFFFFF"/>
-                          </a:solidFill>
-                          <a:latin typeface="Malgun Gothic"/>
-                        </a:rPr>
-                        <a:t>x</a:t>
-                      </a:r>
-                    </a:p>
-                  </a:txBody>
-                  <a:tcPr anchor="ctr" marL="73152" marT="18288" marB="18288">
-                    <a:solidFill>
-                      <a:srgbClr val="1F6FC2"/>
-                    </a:solidFill>
-                  </a:tcPr>
-                </a:tc>
-                <a:tc>
-                  <a:txBody>
-                    <a:bodyPr/>
-                    <a:lstStyle/>
-                    <a:p>
-                      <a:r>
-                        <a:rPr sz="1200" b="1">
-                          <a:solidFill>
-                            <a:srgbClr val="FFFFFF"/>
-                          </a:solidFill>
-                          <a:latin typeface="Malgun Gothic"/>
-                        </a:rPr>
-                        <a:t>y</a:t>
-                      </a:r>
-                    </a:p>
-                  </a:txBody>
-                  <a:tcPr anchor="ctr" marL="73152" marT="18288" marB="18288">
-                    <a:solidFill>
-                      <a:srgbClr val="1F6FC2"/>
-                    </a:solidFill>
-                  </a:tcPr>
-                </a:tc>
-                <a:tc>
-                  <a:txBody>
-                    <a:bodyPr/>
-                    <a:lstStyle/>
-                    <a:p>
-                      <a:r>
-                        <a:rPr sz="1200" b="1">
-                          <a:solidFill>
-                            <a:srgbClr val="FFFFFF"/>
-                          </a:solidFill>
-                          <a:latin typeface="Malgun Gothic"/>
-                        </a:rPr>
-                        <a:t>z</a:t>
-                      </a:r>
-                    </a:p>
-                  </a:txBody>
-                  <a:tcPr anchor="ctr" marL="73152" marT="18288" marB="18288">
-                    <a:solidFill>
-                      <a:srgbClr val="1F6FC2"/>
-                    </a:solidFill>
-                  </a:tcPr>
-                </a:tc>
-              </a:tr>
-              <a:tr h="365760">
-                <a:tc>
-                  <a:txBody>
-                    <a:bodyPr/>
-                    <a:lstStyle/>
-                    <a:p>
-                      <a:r>
-                        <a:rPr sz="1200">
-                          <a:solidFill>
-                            <a:srgbClr val="222426"/>
-                          </a:solidFill>
-                          <a:latin typeface="Malgun Gothic"/>
-                        </a:rPr>
-                        <a:t>x</a:t>
-                      </a:r>
-                    </a:p>
-                  </a:txBody>
-                  <a:tcPr anchor="ctr" marL="73152" marT="18288" marB="18288">
-                    <a:solidFill>
-                      <a:srgbClr val="F4F6F8"/>
-                    </a:solidFill>
-                  </a:tcPr>
-                </a:tc>
-                <a:tc>
-                  <a:txBody>
-                    <a:bodyPr/>
-                    <a:lstStyle/>
-                    <a:p>
-                      <a:r>
-                        <a:rPr sz="1200">
-                          <a:solidFill>
-                            <a:srgbClr val="222426"/>
-                          </a:solidFill>
-                          <a:latin typeface="Malgun Gothic"/>
-                        </a:rPr>
-                        <a:t>4.8515e-04</a:t>
-                      </a:r>
-                    </a:p>
-                  </a:txBody>
-                  <a:tcPr anchor="ctr" marL="73152" marT="18288" marB="18288">
-                    <a:solidFill>
-                      <a:srgbClr val="F4F6F8"/>
-                    </a:solidFill>
-                  </a:tcPr>
-                </a:tc>
-                <a:tc>
-                  <a:txBody>
-                    <a:bodyPr/>
-                    <a:lstStyle/>
-                    <a:p>
-                      <a:r>
-                        <a:rPr sz="1200">
-                          <a:solidFill>
-                            <a:srgbClr val="222426"/>
-                          </a:solidFill>
-                          <a:latin typeface="Malgun Gothic"/>
-                        </a:rPr>
-                        <a:t>3.4617e-07</a:t>
-                      </a:r>
-                    </a:p>
-                  </a:txBody>
-                  <a:tcPr anchor="ctr" marL="73152" marT="18288" marB="18288">
-                    <a:solidFill>
-                      <a:srgbClr val="F4F6F8"/>
-                    </a:solidFill>
-                  </a:tcPr>
-                </a:tc>
-                <a:tc>
-                  <a:txBody>
-                    <a:bodyPr/>
-                    <a:lstStyle/>
-                    <a:p>
-                      <a:r>
-                        <a:rPr sz="1200">
-                          <a:solidFill>
-                            <a:srgbClr val="222426"/>
-                          </a:solidFill>
-                          <a:latin typeface="Malgun Gothic"/>
-                        </a:rPr>
-                        <a:t>-1.2660e-11</a:t>
-                      </a:r>
-                    </a:p>
-                  </a:txBody>
-                  <a:tcPr anchor="ctr" marL="73152" marT="18288" marB="18288">
-                    <a:solidFill>
-                      <a:srgbClr val="F4F6F8"/>
-                    </a:solidFill>
-                  </a:tcPr>
-                </a:tc>
-              </a:tr>
-              <a:tr h="365760">
-                <a:tc>
-                  <a:txBody>
-                    <a:bodyPr/>
-                    <a:lstStyle/>
-                    <a:p>
-                      <a:r>
-                        <a:rPr sz="1200">
-                          <a:solidFill>
-                            <a:srgbClr val="222426"/>
-                          </a:solidFill>
-                          <a:latin typeface="Malgun Gothic"/>
-                        </a:rPr>
-                        <a:t>y</a:t>
-                      </a:r>
-                    </a:p>
-                  </a:txBody>
-                  <a:tcPr anchor="ctr" marL="73152" marT="18288" marB="18288">
-                    <a:solidFill>
-                      <a:srgbClr val="FFFFFF"/>
-                    </a:solidFill>
-                  </a:tcPr>
-                </a:tc>
-                <a:tc>
-                  <a:txBody>
-                    <a:bodyPr/>
-                    <a:lstStyle/>
-                    <a:p>
-                      <a:r>
-                        <a:rPr sz="1200">
-                          <a:solidFill>
-                            <a:srgbClr val="222426"/>
-                          </a:solidFill>
-                          <a:latin typeface="Malgun Gothic"/>
-                        </a:rPr>
-                        <a:t>3.4617e-07</a:t>
-                      </a:r>
-                    </a:p>
-                  </a:txBody>
-                  <a:tcPr anchor="ctr" marL="73152" marT="18288" marB="18288">
-                    <a:solidFill>
-                      <a:srgbClr val="FFFFFF"/>
-                    </a:solidFill>
-                  </a:tcPr>
-                </a:tc>
-                <a:tc>
-                  <a:txBody>
-                    <a:bodyPr/>
-                    <a:lstStyle/>
-                    <a:p>
-                      <a:r>
-                        <a:rPr sz="1200">
-                          <a:solidFill>
-                            <a:srgbClr val="222426"/>
-                          </a:solidFill>
-                          <a:latin typeface="Malgun Gothic"/>
-                        </a:rPr>
-                        <a:t>4.8464e-04</a:t>
-                      </a:r>
-                    </a:p>
-                  </a:txBody>
-                  <a:tcPr anchor="ctr" marL="73152" marT="18288" marB="18288">
-                    <a:solidFill>
-                      <a:srgbClr val="FFFFFF"/>
-                    </a:solidFill>
-                  </a:tcPr>
-                </a:tc>
-                <a:tc>
-                  <a:txBody>
-                    <a:bodyPr/>
-                    <a:lstStyle/>
-                    <a:p>
-                      <a:r>
-                        <a:rPr sz="1200">
-                          <a:solidFill>
-                            <a:srgbClr val="222426"/>
-                          </a:solidFill>
-                          <a:latin typeface="Malgun Gothic"/>
-                        </a:rPr>
-                        <a:t>-7.8781e-08</a:t>
-                      </a:r>
-                    </a:p>
-                  </a:txBody>
-                  <a:tcPr anchor="ctr" marL="73152" marT="18288" marB="18288">
-                    <a:solidFill>
-                      <a:srgbClr val="FFFFFF"/>
-                    </a:solidFill>
-                  </a:tcPr>
-                </a:tc>
-              </a:tr>
-              <a:tr h="365760">
-                <a:tc>
-                  <a:txBody>
-                    <a:bodyPr/>
-                    <a:lstStyle/>
-                    <a:p>
-                      <a:r>
-                        <a:rPr sz="1200">
-                          <a:solidFill>
-                            <a:srgbClr val="222426"/>
-                          </a:solidFill>
-                          <a:latin typeface="Malgun Gothic"/>
-                        </a:rPr>
-                        <a:t>z</a:t>
-                      </a:r>
-                    </a:p>
-                  </a:txBody>
-                  <a:tcPr anchor="ctr" marL="73152" marT="18288" marB="18288">
-                    <a:solidFill>
-                      <a:srgbClr val="F4F6F8"/>
-                    </a:solidFill>
-                  </a:tcPr>
-                </a:tc>
-                <a:tc>
-                  <a:txBody>
-                    <a:bodyPr/>
-                    <a:lstStyle/>
-                    <a:p>
-                      <a:r>
-                        <a:rPr sz="1200">
-                          <a:solidFill>
-                            <a:srgbClr val="222426"/>
-                          </a:solidFill>
-                          <a:latin typeface="Malgun Gothic"/>
-                        </a:rPr>
-                        <a:t>-1.2660e-11</a:t>
-                      </a:r>
-                    </a:p>
-                  </a:txBody>
-                  <a:tcPr anchor="ctr" marL="73152" marT="18288" marB="18288">
-                    <a:solidFill>
-                      <a:srgbClr val="F4F6F8"/>
-                    </a:solidFill>
-                  </a:tcPr>
-                </a:tc>
-                <a:tc>
-                  <a:txBody>
-                    <a:bodyPr/>
-                    <a:lstStyle/>
-                    <a:p>
-                      <a:r>
-                        <a:rPr sz="1200">
-                          <a:solidFill>
-                            <a:srgbClr val="222426"/>
-                          </a:solidFill>
-                          <a:latin typeface="Malgun Gothic"/>
-                        </a:rPr>
-                        <a:t>-7.8781e-08</a:t>
-                      </a:r>
-                    </a:p>
-                  </a:txBody>
-                  <a:tcPr anchor="ctr" marL="73152" marT="18288" marB="18288">
-                    <a:solidFill>
-                      <a:srgbClr val="F4F6F8"/>
-                    </a:solidFill>
-                  </a:tcPr>
-                </a:tc>
-                <a:tc>
-                  <a:txBody>
-                    <a:bodyPr/>
-                    <a:lstStyle/>
-                    <a:p>
-                      <a:r>
-                        <a:rPr sz="1200">
-                          <a:solidFill>
-                            <a:srgbClr val="222426"/>
-                          </a:solidFill>
-                          <a:latin typeface="Malgun Gothic"/>
-                        </a:rPr>
-                        <a:t>2.0359e-04</a:t>
-                      </a:r>
-                    </a:p>
-                  </a:txBody>
-                  <a:tcPr anchor="ctr" marL="73152" marT="18288" marB="18288">
-                    <a:solidFill>
-                      <a:srgbClr val="F4F6F8"/>
-                    </a:solidFill>
-                  </a:tcPr>
-                </a:tc>
-              </a:tr>
-            </a:tbl>
-          </a:graphicData>
-        </a:graphic>
-      </p:graphicFrame>
+        </p:nvPicPr>
+        <p:blipFill>
+          <a:blip r:embed="rId3"/>
+          <a:stretch>
+            <a:fillRect/>
+          </a:stretch>
+        </p:blipFill>
+        <p:spPr>
+          <a:xfrm>
+            <a:off x="7498080" y="1188720"/>
+            <a:ext cx="3108960" cy="2331720"/>
+          </a:xfrm>
+          <a:prstGeom prst="rect">
+            <a:avLst/>
+          </a:prstGeom>
+          <a:ln w="9525">
+            <a:solidFill>
+              <a:srgbClr val="CFD6DE"/>
+            </a:solidFill>
+          </a:ln>
+        </p:spPr>
+      </p:pic>
+      <p:sp>
+        <p:nvSpPr>
+          <p:cNvPr id="6" name="TextBox 5"/>
+          <p:cNvSpPr txBox="1"/>
+          <p:nvPr/>
+        </p:nvSpPr>
+        <p:spPr>
+          <a:xfrm>
+            <a:off x="6355080" y="3547872"/>
+            <a:ext cx="5394960" cy="320040"/>
+          </a:xfrm>
+          <a:prstGeom prst="rect">
+            <a:avLst/>
+          </a:prstGeom>
+          <a:noFill/>
+        </p:spPr>
+        <p:txBody>
+          <a:bodyPr wrap="square">
+            <a:spAutoFit/>
+          </a:bodyPr>
+          <a:lstStyle/>
+          <a:p>
+            <a:pPr algn="ctr"/>
+            <a:r>
+              <a:rPr sz="1100" b="0">
+                <a:solidFill>
+                  <a:srgbClr val="6A6E73"/>
+                </a:solidFill>
+                <a:latin typeface="Malgun Gothic"/>
+              </a:rPr>
+              <a:t>등각 (앞·좌·위)</a:t>
+            </a:r>
+          </a:p>
+        </p:txBody>
+      </p:sp>
+      <p:pic>
+        <p:nvPicPr>
+          <p:cNvPr id="7" name="Picture 6" descr="view_iso3.png"/>
+          <p:cNvPicPr>
+            <a:picLocks noChangeAspect="1"/>
+          </p:cNvPicPr>
+          <p:nvPr/>
+        </p:nvPicPr>
+        <p:blipFill>
+          <a:blip r:embed="rId4"/>
+          <a:stretch>
+            <a:fillRect/>
+          </a:stretch>
+        </p:blipFill>
+        <p:spPr>
+          <a:xfrm>
+            <a:off x="1554480" y="4069080"/>
+            <a:ext cx="3108960" cy="2331720"/>
+          </a:xfrm>
+          <a:prstGeom prst="rect">
+            <a:avLst/>
+          </a:prstGeom>
+          <a:ln w="9525">
+            <a:solidFill>
+              <a:srgbClr val="CFD6DE"/>
+            </a:solidFill>
+          </a:ln>
+        </p:spPr>
+      </p:pic>
+      <p:sp>
+        <p:nvSpPr>
+          <p:cNvPr id="8" name="TextBox 7"/>
+          <p:cNvSpPr txBox="1"/>
+          <p:nvPr/>
+        </p:nvSpPr>
+        <p:spPr>
+          <a:xfrm>
+            <a:off x="411480" y="6428232"/>
+            <a:ext cx="5394960" cy="320040"/>
+          </a:xfrm>
+          <a:prstGeom prst="rect">
+            <a:avLst/>
+          </a:prstGeom>
+          <a:noFill/>
+        </p:spPr>
+        <p:txBody>
+          <a:bodyPr wrap="square">
+            <a:spAutoFit/>
+          </a:bodyPr>
+          <a:lstStyle/>
+          <a:p>
+            <a:pPr algn="ctr"/>
+            <a:r>
+              <a:rPr sz="1100" b="0">
+                <a:solidFill>
+                  <a:srgbClr val="6A6E73"/>
+                </a:solidFill>
+                <a:latin typeface="Malgun Gothic"/>
+              </a:rPr>
+              <a:t>등각 (뒤·좌·위)</a:t>
+            </a:r>
+          </a:p>
+        </p:txBody>
+      </p:sp>
+      <p:pic>
+        <p:nvPicPr>
+          <p:cNvPr id="9" name="Picture 8" descr="view_iso4.png"/>
+          <p:cNvPicPr>
+            <a:picLocks noChangeAspect="1"/>
+          </p:cNvPicPr>
+          <p:nvPr/>
+        </p:nvPicPr>
+        <p:blipFill>
+          <a:blip r:embed="rId5"/>
+          <a:stretch>
+            <a:fillRect/>
+          </a:stretch>
+        </p:blipFill>
+        <p:spPr>
+          <a:xfrm>
+            <a:off x="7498080" y="4069080"/>
+            <a:ext cx="3108960" cy="2331720"/>
+          </a:xfrm>
+          <a:prstGeom prst="rect">
+            <a:avLst/>
+          </a:prstGeom>
+          <a:ln w="9525">
+            <a:solidFill>
+              <a:srgbClr val="CFD6DE"/>
+            </a:solidFill>
+          </a:ln>
+        </p:spPr>
+      </p:pic>
+      <p:sp>
+        <p:nvSpPr>
+          <p:cNvPr id="10" name="TextBox 9"/>
+          <p:cNvSpPr txBox="1"/>
+          <p:nvPr/>
+        </p:nvSpPr>
+        <p:spPr>
+          <a:xfrm>
+            <a:off x="6355080" y="6428232"/>
+            <a:ext cx="5394960" cy="320040"/>
+          </a:xfrm>
+          <a:prstGeom prst="rect">
+            <a:avLst/>
+          </a:prstGeom>
+          <a:noFill/>
+        </p:spPr>
+        <p:txBody>
+          <a:bodyPr wrap="square">
+            <a:spAutoFit/>
+          </a:bodyPr>
+          <a:lstStyle/>
+          <a:p>
+            <a:pPr algn="ctr"/>
+            <a:r>
+              <a:rPr sz="1100" b="0">
+                <a:solidFill>
+                  <a:srgbClr val="6A6E73"/>
+                </a:solidFill>
+                <a:latin typeface="Malgun Gothic"/>
+              </a:rPr>
+              <a:t>등각 (뒤·우·위)</a:t>
+            </a:r>
+          </a:p>
+        </p:txBody>
+      </p:sp>
     </p:spTree>
   </p:cSld>
   <p:clrMapOvr>
@@ -4747,7 +4478,7 @@
                 </a:solidFill>
                 <a:latin typeface="Malgun Gothic"/>
               </a:rPr>
-              <a:t>주요 지름 (원통면, 큰 것부터)</a:t>
+              <a:t>주요 지름 (원통/구멍, 큰 것부터)</a:t>
             </a:r>
           </a:p>
           <a:p>
@@ -6043,7 +5774,7 @@
       </p:graphicFrame>
       <p:pic>
         <p:nvPicPr>
-          <p:cNvPr id="5" name="Picture 4" descr="view_iso.png"/>
+          <p:cNvPr id="5" name="Picture 4" descr="view_top_dim.png"/>
           <p:cNvPicPr>
             <a:picLocks noChangeAspect="1"/>
           </p:cNvPicPr>
@@ -6058,7 +5789,7 @@
         <p:spPr>
           <a:xfrm>
             <a:off x="6446520" y="1417320"/>
-            <a:ext cx="5303520" cy="3977640"/>
+            <a:ext cx="5303520" cy="4053096"/>
           </a:xfrm>
           <a:prstGeom prst="rect">
             <a:avLst/>
@@ -6078,7 +5809,7 @@
         </p:nvSpPr>
         <p:spPr>
           <a:xfrm>
-            <a:off x="6446520" y="5422392"/>
+            <a:off x="6446520" y="5497848"/>
             <a:ext cx="5303520" cy="320040"/>
           </a:xfrm>
           <a:prstGeom prst="rect">
@@ -6100,171 +5831,7 @@
                 </a:solidFill>
                 <a:latin typeface="Malgun Gothic"/>
               </a:rPr>
-              <a:t>원통면 위치 (등각 투상도)</a:t>
-            </a:r>
-          </a:p>
-        </p:txBody>
-      </p:sp>
-    </p:spTree>
-  </p:cSld>
-  <p:clrMapOvr>
-    <a:masterClrMapping/>
-  </p:clrMapOvr>
-</p:sld>
-</file>
-
-<file path=ppt/slides/slide6.xml><?xml version="1.0" encoding="utf-8"?>
-<p:sld xmlns:a="http://schemas.openxmlformats.org/drawingml/2006/main" xmlns:p="http://schemas.openxmlformats.org/presentationml/2006/main" xmlns:r="http://schemas.openxmlformats.org/officeDocument/2006/relationships">
-  <p:cSld>
-    <p:spTree>
-      <p:nvGrpSpPr>
-        <p:cNvPr id="1" name=""/>
-        <p:cNvGrpSpPr/>
-        <p:nvPr/>
-      </p:nvGrpSpPr>
-      <p:grpSpPr/>
-      <p:sp>
-        <p:nvSpPr>
-          <p:cNvPr id="2" name="Rectangle 1"/>
-          <p:cNvSpPr/>
-          <p:nvPr/>
-        </p:nvSpPr>
-        <p:spPr>
-          <a:xfrm>
-            <a:off x="0" y="0"/>
-            <a:ext cx="12191695" cy="960120"/>
-          </a:xfrm>
-          <a:prstGeom prst="rect">
-            <a:avLst/>
-          </a:prstGeom>
-          <a:solidFill>
-            <a:srgbClr val="1F6FC2"/>
-          </a:solidFill>
-          <a:ln>
-            <a:noFill/>
-          </a:ln>
-        </p:spPr>
-        <p:style>
-          <a:lnRef idx="1">
-            <a:schemeClr val="accent1"/>
-          </a:lnRef>
-          <a:fillRef idx="3">
-            <a:schemeClr val="accent1"/>
-          </a:fillRef>
-          <a:effectRef idx="2">
-            <a:schemeClr val="accent1"/>
-          </a:effectRef>
-          <a:fontRef idx="minor">
-            <a:schemeClr val="lt1"/>
-          </a:fontRef>
-        </p:style>
-        <p:txBody>
-          <a:bodyPr rtlCol="0" anchor="ctr" lIns="365760" tIns="109728"/>
-          <a:lstStyle/>
-          <a:p>
-            <a:pPr algn="ctr"/>
-            <a:r>
-              <a:rPr sz="2600" b="1">
-                <a:solidFill>
-                  <a:srgbClr val="FFFFFF"/>
-                </a:solidFill>
-                <a:latin typeface="Malgun Gothic"/>
-              </a:rPr>
-              <a:t>URDF &lt;inertial&gt; (로봇 링크)</a:t>
-            </a:r>
-          </a:p>
-          <a:p>
-            <a:r>
-              <a:rPr sz="1200">
-                <a:solidFill>
-                  <a:srgbClr val="DDEAF8"/>
-                </a:solidFill>
-                <a:latin typeface="Malgun Gothic"/>
-              </a:rPr>
-              <a:t>HSHG17_2stage_planetary_gear.step</a:t>
-            </a:r>
-          </a:p>
-        </p:txBody>
-      </p:sp>
-      <p:sp>
-        <p:nvSpPr>
-          <p:cNvPr id="3" name="TextBox 2"/>
-          <p:cNvSpPr txBox="1"/>
-          <p:nvPr/>
-        </p:nvSpPr>
-        <p:spPr>
-          <a:xfrm>
-            <a:off x="548640" y="1234440"/>
-            <a:ext cx="11064240" cy="5029200"/>
-          </a:xfrm>
-          <a:prstGeom prst="rect">
-            <a:avLst/>
-          </a:prstGeom>
-          <a:noFill/>
-        </p:spPr>
-        <p:txBody>
-          <a:bodyPr wrap="square">
-            <a:spAutoFit/>
-          </a:bodyPr>
-          <a:lstStyle/>
-          <a:p>
-            <a:pPr algn="l"/>
-            <a:r>
-              <a:rPr sz="1400" b="0">
-                <a:solidFill>
-                  <a:srgbClr val="222426"/>
-                </a:solidFill>
-                <a:latin typeface="Consolas"/>
-              </a:rPr>
-              <a:t>&lt;inertial&gt;</a:t>
-            </a:r>
-          </a:p>
-          <a:p>
-            <a:pPr algn="l"/>
-            <a:r>
-              <a:rPr sz="1400" b="0">
-                <a:solidFill>
-                  <a:srgbClr val="222426"/>
-                </a:solidFill>
-                <a:latin typeface="Consolas"/>
-              </a:rPr>
-              <a:t>  &lt;origin xyz="-8.52116e-10 2.25946e-06 0.0390866" rpy="0 0 0"/&gt;</a:t>
-            </a:r>
-          </a:p>
-          <a:p>
-            <a:pPr algn="l"/>
-            <a:r>
-              <a:rPr sz="1400" b="0">
-                <a:solidFill>
-                  <a:srgbClr val="222426"/>
-                </a:solidFill>
-                <a:latin typeface="Consolas"/>
-              </a:rPr>
-              <a:t>  &lt;mass value="0.812216"/&gt;</a:t>
-            </a:r>
-          </a:p>
-          <a:p>
-            <a:pPr algn="l"/>
-            <a:r>
-              <a:rPr sz="1400" b="0">
-                <a:solidFill>
-                  <a:srgbClr val="222426"/>
-                </a:solidFill>
-                <a:latin typeface="Consolas"/>
-              </a:rPr>
-              <a:t>  &lt;inertia ixx="0.000485152" ixy="3.46175e-07" ixz="-1.26598e-11" iyy="0.000484636" iyz="-7.87812e-08" izz="0.000203592"/&gt;</a:t>
-            </a:r>
-          </a:p>
-          <a:p>
-            <a:pPr algn="l"/>
-            <a:r>
-              <a:rPr sz="1400" b="0">
-                <a:solidFill>
-                  <a:srgbClr val="222426"/>
-                </a:solidFill>
-                <a:latin typeface="Consolas"/>
-              </a:rPr>
-              <a:t>&lt;/inertial&gt;</a:t>
+              <a:t>원통/구멍 위치 (평면도)</a:t>
             </a:r>
           </a:p>
         </p:txBody>

</xml_diff>